<commit_message>
Delete lidar video and update slide decks
Remove 4.3/lidar_camera_fusion.mp4 and replace two slide binaries in 4.3/slides: P3_N4_Path_Tracking.pptx and P3_N5_Capstone.pptx have been updated with new versions. This commit updates the presentation assets and removes the obsolete video file.
</commit_message>
<xml_diff>
--- a/4.3/slides/P3_N4_Path_Tracking.pptx
+++ b/4.3/slides/P3_N4_Path_Tracking.pptx
@@ -17,6 +17,9 @@
     <p:sldId id="260" r:id="rId13"/>
     <p:sldId id="261" r:id="rId14"/>
     <p:sldId id="262" r:id="rId15"/>
+    <p:sldId id="263" r:id="rId16"/>
+    <p:sldId id="264" r:id="rId9"/>
+    <p:sldId id="265" r:id="rId18"/>
   </p:sldIdLst>
   <p:sldSz cy="6858000" cx="12192000"/>
   <p:notesSz cx="6858000" cy="9144000"/>
@@ -1859,26 +1862,641 @@
           </a:bodyPr>
           <a:lstStyle/>
           <a:p>
-            <a:pPr indent="0" lvl="0" marL="0" rtl="0" algn="l">
-              <a:lnSpc>
-                <a:spcPct val="100000"/>
-              </a:lnSpc>
-              <a:spcBef>
-                <a:spcPts val="0"/>
-              </a:spcBef>
-              <a:spcAft>
-                <a:spcPts val="0"/>
-              </a:spcAft>
-              <a:buSzPts val="1400"/>
-              <a:buNone/>
-            </a:pPr>
             <a:r>
-              <a:rPr lang="en-US"/>
-              <a:t> </a:t>
+              <a:t>Open here. Remind them where we are in the arc: 4.2 detected per frame, N1 fused the sensors, N2 estimated, N3 tracked. Every one of those is PERCEPTION — understanding the world. This lecture is the pivot to ACTION: turning that understanding into a steering command. Keep it to ~30 min; the depth is in the notebook.</a:t>
             </a:r>
-            <a:endParaRPr/>
           </a:p>
         </p:txBody>
+      </p:sp>
+    </p:spTree>
+  </p:cSld>
+  <p:clrMapOvr>
+    <a:masterClrMapping/>
+  </p:clrMapOvr>
+</p:notes>
+</file>
+
+<file path=ppt/notesSlides/notesSlide10.xml><?xml version="1.0" encoding="utf-8"?>
+<p:notes xmlns:a="http://schemas.openxmlformats.org/drawingml/2006/main" xmlns:p="http://schemas.openxmlformats.org/presentationml/2006/main" xmlns:r="http://schemas.openxmlformats.org/officeDocument/2006/relationships">
+  <p:cSld>
+    <p:spTree>
+      <p:nvGrpSpPr>
+        <p:cNvPr id="1" name=""/>
+        <p:cNvGrpSpPr/>
+        <p:nvPr/>
+      </p:nvGrpSpPr>
+      <p:grpSpPr>
+        <a:xfrm>
+          <a:off x="0" y="0"/>
+          <a:ext cx="0" cy="0"/>
+          <a:chOff x="0" y="0"/>
+          <a:chExt cx="0" cy="0"/>
+        </a:xfrm>
+      </p:grpSpPr>
+      <p:sp>
+        <p:nvSpPr>
+          <p:cNvPr id="2" name="Slide Image Placeholder 1"/>
+          <p:cNvSpPr>
+            <a:spLocks noGrp="1"/>
+          </p:cNvSpPr>
+          <p:nvPr>
+            <p:ph type="sldImg" idx="3"/>
+          </p:nvPr>
+        </p:nvSpPr>
+        <p:spPr/>
+      </p:sp>
+      <p:sp>
+        <p:nvSpPr>
+          <p:cNvPr id="3" name="Notes Placeholder 2"/>
+          <p:cNvSpPr>
+            <a:spLocks noGrp="1"/>
+          </p:cNvSpPr>
+          <p:nvPr>
+            <p:ph type="body" idx="1"/>
+          </p:nvPr>
+        </p:nvSpPr>
+        <p:spPr/>
+        <p:txBody>
+          <a:bodyPr/>
+          <a:lstStyle/>
+          <a:p>
+            <a:r>
+              <a:t>Close the lecture by grounding it. Everything so far was a clean synthetic course — good for LEARNING. But the same pure-pursuit code, unchanged, tracks the real trajectory the KITTI car drove (drive 0005). Point at the bird's-eye plot — note the convention flips to forward-UP to match N3, so the whole workshop shares one view. Then the hand-off: 'in the capstone we drive this exact route, but now there are cars in the way — that's where perception and control finally meet.' Transition to N5.</a:t>
+            </a:r>
+          </a:p>
+        </p:txBody>
+      </p:sp>
+      <p:sp>
+        <p:nvSpPr>
+          <p:cNvPr id="4" name="Slide Number Placeholder 3"/>
+          <p:cNvSpPr>
+            <a:spLocks noGrp="1"/>
+          </p:cNvSpPr>
+          <p:nvPr>
+            <p:ph type="sldNum" idx="12"/>
+          </p:nvPr>
+        </p:nvSpPr>
+        <p:spPr/>
+      </p:sp>
+    </p:spTree>
+  </p:cSld>
+  <p:clrMapOvr>
+    <a:masterClrMapping/>
+  </p:clrMapOvr>
+</p:notes>
+</file>
+
+<file path=ppt/notesSlides/notesSlide2.xml><?xml version="1.0" encoding="utf-8"?>
+<p:notes xmlns:a="http://schemas.openxmlformats.org/drawingml/2006/main" xmlns:p="http://schemas.openxmlformats.org/presentationml/2006/main" xmlns:r="http://schemas.openxmlformats.org/officeDocument/2006/relationships">
+  <p:cSld>
+    <p:spTree>
+      <p:nvGrpSpPr>
+        <p:cNvPr id="1" name=""/>
+        <p:cNvGrpSpPr/>
+        <p:nvPr/>
+      </p:nvGrpSpPr>
+      <p:grpSpPr>
+        <a:xfrm>
+          <a:off x="0" y="0"/>
+          <a:ext cx="0" cy="0"/>
+          <a:chOff x="0" y="0"/>
+          <a:chExt cx="0" cy="0"/>
+        </a:xfrm>
+      </p:grpSpPr>
+      <p:sp>
+        <p:nvSpPr>
+          <p:cNvPr id="2" name="Slide Image Placeholder 1"/>
+          <p:cNvSpPr>
+            <a:spLocks noGrp="1"/>
+          </p:cNvSpPr>
+          <p:nvPr>
+            <p:ph type="sldImg" idx="3"/>
+          </p:nvPr>
+        </p:nvSpPr>
+        <p:spPr/>
+      </p:sp>
+      <p:sp>
+        <p:nvSpPr>
+          <p:cNvPr id="3" name="Notes Placeholder 2"/>
+          <p:cNvSpPr>
+            <a:spLocks noGrp="1"/>
+          </p:cNvSpPr>
+          <p:nvPr>
+            <p:ph type="body" idx="1"/>
+          </p:nvPr>
+        </p:nvSpPr>
+        <p:spPr/>
+        <p:txBody>
+          <a:bodyPr/>
+          <a:lstStyle/>
+          <a:p>
+            <a:r>
+              <a:t>Call back explicitly to N2's last slide ('an observer, not a controller'). That module IS this lecture. Frame the job narrowly: we are NOT planning the route (that was 4.2's A*); we are EXECUTING it — given a path and where we are, output a steering angle each tick. Stress 'no learning': these are 1980s-90s geometry, still shipping in real cars today, because they're simple and debuggable. Set up the two we'll cover: pure pursuit and Stanley.</a:t>
+            </a:r>
+          </a:p>
+        </p:txBody>
+      </p:sp>
+      <p:sp>
+        <p:nvSpPr>
+          <p:cNvPr id="4" name="Slide Number Placeholder 3"/>
+          <p:cNvSpPr>
+            <a:spLocks noGrp="1"/>
+          </p:cNvSpPr>
+          <p:nvPr>
+            <p:ph type="sldNum" idx="12"/>
+          </p:nvPr>
+        </p:nvSpPr>
+        <p:spPr/>
+      </p:sp>
+    </p:spTree>
+  </p:cSld>
+  <p:clrMapOvr>
+    <a:masterClrMapping/>
+  </p:clrMapOvr>
+</p:notes>
+</file>
+
+<file path=ppt/notesSlides/notesSlide3.xml><?xml version="1.0" encoding="utf-8"?>
+<p:notes xmlns:a="http://schemas.openxmlformats.org/drawingml/2006/main" xmlns:p="http://schemas.openxmlformats.org/presentationml/2006/main" xmlns:r="http://schemas.openxmlformats.org/officeDocument/2006/relationships">
+  <p:cSld>
+    <p:spTree>
+      <p:nvGrpSpPr>
+        <p:cNvPr id="1" name=""/>
+        <p:cNvGrpSpPr/>
+        <p:nvPr/>
+      </p:nvGrpSpPr>
+      <p:grpSpPr>
+        <a:xfrm>
+          <a:off x="0" y="0"/>
+          <a:ext cx="0" cy="0"/>
+          <a:chOff x="0" y="0"/>
+          <a:chExt cx="0" cy="0"/>
+        </a:xfrm>
+      </p:grpSpPr>
+      <p:sp>
+        <p:nvSpPr>
+          <p:cNvPr id="2" name="Slide Image Placeholder 1"/>
+          <p:cNvSpPr>
+            <a:spLocks noGrp="1"/>
+          </p:cNvSpPr>
+          <p:nvPr>
+            <p:ph type="sldImg" idx="3"/>
+          </p:nvPr>
+        </p:nvSpPr>
+        <p:spPr/>
+      </p:sp>
+      <p:sp>
+        <p:nvSpPr>
+          <p:cNvPr id="3" name="Notes Placeholder 2"/>
+          <p:cNvSpPr>
+            <a:spLocks noGrp="1"/>
+          </p:cNvSpPr>
+          <p:nvPr>
+            <p:ph type="body" idx="1"/>
+          </p:nvPr>
+        </p:nvSpPr>
+        <p:spPr/>
+        <p:txBody>
+          <a:bodyPr/>
+          <a:lstStyle/>
+          <a:p>
+            <a:r>
+              <a:t>Motivate the abstraction: a real car has 4 wheels, suspension, tire slip — intractable. The bicycle model collapses each axle to one wheel and ignores slip (valid at workshop speeds). Point at the figure: rear axle is the reference point, the front wheel turns by delta, wheelbase L sets how sharply heading changes. Four numbers describe the car: position x,y, heading psi, speed v. Two inputs: steering and acceleration. Tell them the equations are next.</a:t>
+            </a:r>
+          </a:p>
+        </p:txBody>
+      </p:sp>
+      <p:sp>
+        <p:nvSpPr>
+          <p:cNvPr id="4" name="Slide Number Placeholder 3"/>
+          <p:cNvSpPr>
+            <a:spLocks noGrp="1"/>
+          </p:cNvSpPr>
+          <p:nvPr>
+            <p:ph type="sldNum" idx="12"/>
+          </p:nvPr>
+        </p:nvSpPr>
+        <p:spPr/>
+      </p:sp>
+    </p:spTree>
+  </p:cSld>
+  <p:clrMapOvr>
+    <a:masterClrMapping/>
+  </p:clrMapOvr>
+</p:notes>
+</file>
+
+<file path=ppt/notesSlides/notesSlide4.xml><?xml version="1.0" encoding="utf-8"?>
+<p:notes xmlns:a="http://schemas.openxmlformats.org/drawingml/2006/main" xmlns:p="http://schemas.openxmlformats.org/presentationml/2006/main" xmlns:r="http://schemas.openxmlformats.org/officeDocument/2006/relationships">
+  <p:cSld>
+    <p:spTree>
+      <p:nvGrpSpPr>
+        <p:cNvPr id="1" name=""/>
+        <p:cNvGrpSpPr/>
+        <p:nvPr/>
+      </p:nvGrpSpPr>
+      <p:grpSpPr>
+        <a:xfrm>
+          <a:off x="0" y="0"/>
+          <a:ext cx="0" cy="0"/>
+          <a:chOff x="0" y="0"/>
+          <a:chExt cx="0" cy="0"/>
+        </a:xfrm>
+      </p:grpSpPr>
+      <p:sp>
+        <p:nvSpPr>
+          <p:cNvPr id="2" name="Slide Image Placeholder 1"/>
+          <p:cNvSpPr>
+            <a:spLocks noGrp="1"/>
+          </p:cNvSpPr>
+          <p:nvPr>
+            <p:ph type="sldImg" idx="3"/>
+          </p:nvPr>
+        </p:nvSpPr>
+        <p:spPr/>
+      </p:sp>
+      <p:sp>
+        <p:nvSpPr>
+          <p:cNvPr id="3" name="Notes Placeholder 2"/>
+          <p:cNvSpPr>
+            <a:spLocks noGrp="1"/>
+          </p:cNvSpPr>
+          <p:nvPr>
+            <p:ph type="body" idx="1"/>
+          </p:nvPr>
+        </p:nvSpPr>
+        <p:spPr/>
+        <p:txBody>
+          <a:bodyPr/>
+          <a:lstStyle/>
+          <a:p>
+            <a:r>
+              <a:t>Walk the equations left to right. x-dot and y-dot: the car moves in the direction it's pointing at speed v — pure trigonometry. psi-dot = (v/L) tan(delta) is the only subtle one: turn the wheel and heading changes FASTER the faster you go and the SHORTER the wheelbase — that's why a bus needs a bigger turning circle than a go-kart. v-dot = a is just throttle/brake. Emphasize there's no force or mass here — it's KINEMATIC, geometry of motion, not dynamics. In code it's one Euler step; mention RK4 if someone asks about accuracy.</a:t>
+            </a:r>
+          </a:p>
+        </p:txBody>
+      </p:sp>
+      <p:sp>
+        <p:nvSpPr>
+          <p:cNvPr id="4" name="Slide Number Placeholder 3"/>
+          <p:cNvSpPr>
+            <a:spLocks noGrp="1"/>
+          </p:cNvSpPr>
+          <p:nvPr>
+            <p:ph type="sldNum" idx="12"/>
+          </p:nvPr>
+        </p:nvSpPr>
+        <p:spPr/>
+      </p:sp>
+    </p:spTree>
+  </p:cSld>
+  <p:clrMapOvr>
+    <a:masterClrMapping/>
+  </p:clrMapOvr>
+</p:notes>
+</file>
+
+<file path=ppt/notesSlides/notesSlide5.xml><?xml version="1.0" encoding="utf-8"?>
+<p:notes xmlns:a="http://schemas.openxmlformats.org/drawingml/2006/main" xmlns:p="http://schemas.openxmlformats.org/presentationml/2006/main" xmlns:r="http://schemas.openxmlformats.org/officeDocument/2006/relationships">
+  <p:cSld>
+    <p:spTree>
+      <p:nvGrpSpPr>
+        <p:cNvPr id="1" name=""/>
+        <p:cNvGrpSpPr/>
+        <p:nvPr/>
+      </p:nvGrpSpPr>
+      <p:grpSpPr>
+        <a:xfrm>
+          <a:off x="0" y="0"/>
+          <a:ext cx="0" cy="0"/>
+          <a:chOff x="0" y="0"/>
+          <a:chExt cx="0" cy="0"/>
+        </a:xfrm>
+      </p:grpSpPr>
+      <p:sp>
+        <p:nvSpPr>
+          <p:cNvPr id="2" name="Slide Image Placeholder 1"/>
+          <p:cNvSpPr>
+            <a:spLocks noGrp="1"/>
+          </p:cNvSpPr>
+          <p:nvPr>
+            <p:ph type="sldImg" idx="3"/>
+          </p:nvPr>
+        </p:nvSpPr>
+        <p:spPr/>
+      </p:sp>
+      <p:sp>
+        <p:nvSpPr>
+          <p:cNvPr id="3" name="Notes Placeholder 2"/>
+          <p:cNvSpPr>
+            <a:spLocks noGrp="1"/>
+          </p:cNvSpPr>
+          <p:nvPr>
+            <p:ph type="body" idx="1"/>
+          </p:nvPr>
+        </p:nvSpPr>
+        <p:spPr/>
+        <p:txBody>
+          <a:bodyPr/>
+          <a:lstStyle/>
+          <a:p>
+            <a:r>
+              <a:t>Best intuition: it's how a human drives — you don't stare at your bumper, you look down the road at a point and aim for it. Pick a point on the path a fixed distance L_d ahead (the figure), steer to follow a circular arc to it. The ONE knob is L_d. Make them feel the tradeoff before the math: short lookahead = you react to every wiggle = twitchy/oscillates; long lookahead = you smooth everything out but cut corners. This sets up the tuning-sweep slide.</a:t>
+            </a:r>
+          </a:p>
+        </p:txBody>
+      </p:sp>
+      <p:sp>
+        <p:nvSpPr>
+          <p:cNvPr id="4" name="Slide Number Placeholder 3"/>
+          <p:cNvSpPr>
+            <a:spLocks noGrp="1"/>
+          </p:cNvSpPr>
+          <p:nvPr>
+            <p:ph type="sldNum" idx="12"/>
+          </p:nvPr>
+        </p:nvSpPr>
+        <p:spPr/>
+      </p:sp>
+    </p:spTree>
+  </p:cSld>
+  <p:clrMapOvr>
+    <a:masterClrMapping/>
+  </p:clrMapOvr>
+</p:notes>
+</file>
+
+<file path=ppt/notesSlides/notesSlide6.xml><?xml version="1.0" encoding="utf-8"?>
+<p:notes xmlns:a="http://schemas.openxmlformats.org/drawingml/2006/main" xmlns:p="http://schemas.openxmlformats.org/presentationml/2006/main" xmlns:r="http://schemas.openxmlformats.org/officeDocument/2006/relationships">
+  <p:cSld>
+    <p:spTree>
+      <p:nvGrpSpPr>
+        <p:cNvPr id="1" name=""/>
+        <p:cNvGrpSpPr/>
+        <p:nvPr/>
+      </p:nvGrpSpPr>
+      <p:grpSpPr>
+        <a:xfrm>
+          <a:off x="0" y="0"/>
+          <a:ext cx="0" cy="0"/>
+          <a:chOff x="0" y="0"/>
+          <a:chExt cx="0" cy="0"/>
+        </a:xfrm>
+      </p:grpSpPr>
+      <p:sp>
+        <p:nvSpPr>
+          <p:cNvPr id="2" name="Slide Image Placeholder 1"/>
+          <p:cNvSpPr>
+            <a:spLocks noGrp="1"/>
+          </p:cNvSpPr>
+          <p:nvPr>
+            <p:ph type="sldImg" idx="3"/>
+          </p:nvPr>
+        </p:nvSpPr>
+        <p:spPr/>
+      </p:sp>
+      <p:sp>
+        <p:nvSpPr>
+          <p:cNvPr id="3" name="Notes Placeholder 2"/>
+          <p:cNvSpPr>
+            <a:spLocks noGrp="1"/>
+          </p:cNvSpPr>
+          <p:nvPr>
+            <p:ph type="body" idx="1"/>
+          </p:nvPr>
+        </p:nvSpPr>
+        <p:spPr/>
+        <p:txBody>
+          <a:bodyPr/>
+          <a:lstStyle/>
+          <a:p>
+            <a:r>
+              <a:t>Two lines. First, alpha: the angle between where we're pointing and the lookahead point (atan2 of the relative position, minus our heading). Second, the steering law: delta = arctan(2L sin alpha / L_d). Where it comes from: there's a unique circle through the rear axle that passes through the lookahead point; its curvature is 2 sin(alpha)/L_d, and arctan(L * curvature) gives the wheel angle for the bicycle model. Don't belabor the geometry proof — the takeaway is delta falls out of pure geometry, and L_d in the denominator is exactly why bigger lookahead = gentler steering.</a:t>
+            </a:r>
+          </a:p>
+        </p:txBody>
+      </p:sp>
+      <p:sp>
+        <p:nvSpPr>
+          <p:cNvPr id="4" name="Slide Number Placeholder 3"/>
+          <p:cNvSpPr>
+            <a:spLocks noGrp="1"/>
+          </p:cNvSpPr>
+          <p:nvPr>
+            <p:ph type="sldNum" idx="12"/>
+          </p:nvPr>
+        </p:nvSpPr>
+        <p:spPr/>
+      </p:sp>
+    </p:spTree>
+  </p:cSld>
+  <p:clrMapOvr>
+    <a:masterClrMapping/>
+  </p:clrMapOvr>
+</p:notes>
+</file>
+
+<file path=ppt/notesSlides/notesSlide7.xml><?xml version="1.0" encoding="utf-8"?>
+<p:notes xmlns:a="http://schemas.openxmlformats.org/drawingml/2006/main" xmlns:p="http://schemas.openxmlformats.org/presentationml/2006/main" xmlns:r="http://schemas.openxmlformats.org/officeDocument/2006/relationships">
+  <p:cSld>
+    <p:spTree>
+      <p:nvGrpSpPr>
+        <p:cNvPr id="1" name=""/>
+        <p:cNvGrpSpPr/>
+        <p:nvPr/>
+      </p:nvGrpSpPr>
+      <p:grpSpPr>
+        <a:xfrm>
+          <a:off x="0" y="0"/>
+          <a:ext cx="0" cy="0"/>
+          <a:chOff x="0" y="0"/>
+          <a:chExt cx="0" cy="0"/>
+        </a:xfrm>
+      </p:grpSpPr>
+      <p:sp>
+        <p:nvSpPr>
+          <p:cNvPr id="2" name="Slide Image Placeholder 1"/>
+          <p:cNvSpPr>
+            <a:spLocks noGrp="1"/>
+          </p:cNvSpPr>
+          <p:nvPr>
+            <p:ph type="sldImg" idx="3"/>
+          </p:nvPr>
+        </p:nvSpPr>
+        <p:spPr/>
+      </p:sp>
+      <p:sp>
+        <p:nvSpPr>
+          <p:cNvPr id="3" name="Notes Placeholder 2"/>
+          <p:cNvSpPr>
+            <a:spLocks noGrp="1"/>
+          </p:cNvSpPr>
+          <p:nvPr>
+            <p:ph type="body" idx="1"/>
+          </p:nvPr>
+        </p:nvSpPr>
+        <p:spPr/>
+        <p:txBody>
+          <a:bodyPr/>
+          <a:lstStyle/>
+          <a:p>
+            <a:r>
+              <a:t>History hook: this is the controller on Stanley, the VW that won the 2005 DARPA Grand Challenge — students like that. Key difference from pure pursuit: it references the FRONT axle and it looks at TWO errors at once — how wrong the heading is AND how far off the path you are laterally. Point at the figure: Stanley's cross-track error curve sits lower than pure pursuit's — it hugs the path tighter. Trade-off: it can be more aggressive/sensitive to noise.</a:t>
+            </a:r>
+          </a:p>
+        </p:txBody>
+      </p:sp>
+      <p:sp>
+        <p:nvSpPr>
+          <p:cNvPr id="4" name="Slide Number Placeholder 3"/>
+          <p:cNvSpPr>
+            <a:spLocks noGrp="1"/>
+          </p:cNvSpPr>
+          <p:nvPr>
+            <p:ph type="sldNum" idx="12"/>
+          </p:nvPr>
+        </p:nvSpPr>
+        <p:spPr/>
+      </p:sp>
+    </p:spTree>
+  </p:cSld>
+  <p:clrMapOvr>
+    <a:masterClrMapping/>
+  </p:clrMapOvr>
+</p:notes>
+</file>
+
+<file path=ppt/notesSlides/notesSlide8.xml><?xml version="1.0" encoding="utf-8"?>
+<p:notes xmlns:a="http://schemas.openxmlformats.org/drawingml/2006/main" xmlns:p="http://schemas.openxmlformats.org/presentationml/2006/main" xmlns:r="http://schemas.openxmlformats.org/officeDocument/2006/relationships">
+  <p:cSld>
+    <p:spTree>
+      <p:nvGrpSpPr>
+        <p:cNvPr id="1" name=""/>
+        <p:cNvGrpSpPr/>
+        <p:nvPr/>
+      </p:nvGrpSpPr>
+      <p:grpSpPr>
+        <a:xfrm>
+          <a:off x="0" y="0"/>
+          <a:ext cx="0" cy="0"/>
+          <a:chOff x="0" y="0"/>
+          <a:chExt cx="0" cy="0"/>
+        </a:xfrm>
+      </p:grpSpPr>
+      <p:sp>
+        <p:nvSpPr>
+          <p:cNvPr id="2" name="Slide Image Placeholder 1"/>
+          <p:cNvSpPr>
+            <a:spLocks noGrp="1"/>
+          </p:cNvSpPr>
+          <p:nvPr>
+            <p:ph type="sldImg" idx="3"/>
+          </p:nvPr>
+        </p:nvSpPr>
+        <p:spPr/>
+      </p:sp>
+      <p:sp>
+        <p:nvSpPr>
+          <p:cNvPr id="3" name="Notes Placeholder 2"/>
+          <p:cNvSpPr>
+            <a:spLocks noGrp="1"/>
+          </p:cNvSpPr>
+          <p:nvPr>
+            <p:ph type="body" idx="1"/>
+          </p:nvPr>
+        </p:nvSpPr>
+        <p:spPr/>
+        <p:txBody>
+          <a:bodyPr/>
+          <a:lstStyle/>
+          <a:p>
+            <a:r>
+              <a:t>Read it as two jobs added together. Term one, (psi_path - psi): just align with the path's direction. Term two, arctan(k e / v): if you're off the line by e meters, steer back; gain k sets how hard. Two things to highlight: the arctan keeps the correction bounded (never commands an insane angle for a big error), and dividing by v means at high speed the SAME lateral error produces a GENTLER correction — which is what keeps it stable fast. Contrast with pure pursuit's single geometric law: Stanley is explicit error feedback.</a:t>
+            </a:r>
+          </a:p>
+        </p:txBody>
+      </p:sp>
+      <p:sp>
+        <p:nvSpPr>
+          <p:cNvPr id="4" name="Slide Number Placeholder 3"/>
+          <p:cNvSpPr>
+            <a:spLocks noGrp="1"/>
+          </p:cNvSpPr>
+          <p:nvPr>
+            <p:ph type="sldNum" idx="12"/>
+          </p:nvPr>
+        </p:nvSpPr>
+        <p:spPr/>
+      </p:sp>
+    </p:spTree>
+  </p:cSld>
+  <p:clrMapOvr>
+    <a:masterClrMapping/>
+  </p:clrMapOvr>
+</p:notes>
+</file>
+
+<file path=ppt/notesSlides/notesSlide9.xml><?xml version="1.0" encoding="utf-8"?>
+<p:notes xmlns:a="http://schemas.openxmlformats.org/drawingml/2006/main" xmlns:p="http://schemas.openxmlformats.org/presentationml/2006/main" xmlns:r="http://schemas.openxmlformats.org/officeDocument/2006/relationships">
+  <p:cSld>
+    <p:spTree>
+      <p:nvGrpSpPr>
+        <p:cNvPr id="1" name=""/>
+        <p:cNvGrpSpPr/>
+        <p:nvPr/>
+      </p:nvGrpSpPr>
+      <p:grpSpPr>
+        <a:xfrm>
+          <a:off x="0" y="0"/>
+          <a:ext cx="0" cy="0"/>
+          <a:chOff x="0" y="0"/>
+          <a:chExt cx="0" cy="0"/>
+        </a:xfrm>
+      </p:grpSpPr>
+      <p:sp>
+        <p:nvSpPr>
+          <p:cNvPr id="2" name="Slide Image Placeholder 1"/>
+          <p:cNvSpPr>
+            <a:spLocks noGrp="1"/>
+          </p:cNvSpPr>
+          <p:nvPr>
+            <p:ph type="sldImg" idx="3"/>
+          </p:nvPr>
+        </p:nvSpPr>
+        <p:spPr/>
+      </p:sp>
+      <p:sp>
+        <p:nvSpPr>
+          <p:cNvPr id="3" name="Notes Placeholder 2"/>
+          <p:cNvSpPr>
+            <a:spLocks noGrp="1"/>
+          </p:cNvSpPr>
+          <p:nvPr>
+            <p:ph type="body" idx="1"/>
+          </p:nvPr>
+        </p:nvSpPr>
+        <p:spPr/>
+        <p:txBody>
+          <a:bodyPr/>
+          <a:lstStyle/>
+          <a:p>
+            <a:r>
+              <a:t>This figure is REAL output from the notebook — three pure-pursuit runs at lookahead 3, 8, 20 m. Walk the curves: the short one tracks tightly but you can see it wiggling; the long one is smooth but bows out on the turns (cuts corners); 8 m is the sweet spot. The lesson generalizes to every controller: there's no free lunch, you trade responsiveness against smoothness, and the right value depends on speed. In the notebook they get to drag this knob themselves — encourage it.</a:t>
+            </a:r>
+          </a:p>
+        </p:txBody>
+      </p:sp>
+      <p:sp>
+        <p:nvSpPr>
+          <p:cNvPr id="4" name="Slide Number Placeholder 3"/>
+          <p:cNvSpPr>
+            <a:spLocks noGrp="1"/>
+          </p:cNvSpPr>
+          <p:nvPr>
+            <p:ph type="sldNum" idx="12"/>
+          </p:nvPr>
+        </p:nvSpPr>
+        <p:spPr/>
       </p:sp>
     </p:spTree>
   </p:cSld>
@@ -30819,6 +31437,147 @@
 </p:sld>
 </file>
 
+<file path=ppt/slides/slide10.xml><?xml version="1.0" encoding="utf-8"?>
+<p:sld xmlns:a="http://schemas.openxmlformats.org/drawingml/2006/main" xmlns:p="http://schemas.openxmlformats.org/presentationml/2006/main" xmlns:r="http://schemas.openxmlformats.org/officeDocument/2006/relationships">
+  <p:cSld>
+    <p:spTree>
+      <p:nvGrpSpPr>
+        <p:cNvPr id="1" name=""/>
+        <p:cNvGrpSpPr/>
+        <p:nvPr/>
+      </p:nvGrpSpPr>
+      <p:grpSpPr/>
+      <p:sp>
+        <p:nvSpPr>
+          <p:cNvPr id="2" name="Title 1"/>
+          <p:cNvSpPr>
+            <a:spLocks noGrp="1"/>
+          </p:cNvSpPr>
+          <p:nvPr>
+            <p:ph type="title"/>
+          </p:nvPr>
+        </p:nvSpPr>
+        <p:spPr/>
+        <p:txBody>
+          <a:bodyPr/>
+          <a:lstStyle/>
+          <a:p>
+            <a:r>
+              <a:rPr>
+                <a:latin typeface="Verdana"/>
+              </a:rPr>
+              <a:t>Tracking the real route</a:t>
+            </a:r>
+          </a:p>
+        </p:txBody>
+      </p:sp>
+      <p:sp>
+        <p:nvSpPr>
+          <p:cNvPr id="3" name="TextBox 2"/>
+          <p:cNvSpPr txBox="1"/>
+          <p:nvPr/>
+        </p:nvSpPr>
+        <p:spPr>
+          <a:xfrm>
+            <a:off x="502920" y="1600200"/>
+            <a:ext cx="4297680" cy="4572000"/>
+          </a:xfrm>
+          <a:prstGeom prst="rect">
+            <a:avLst/>
+          </a:prstGeom>
+          <a:noFill/>
+        </p:spPr>
+        <p:txBody>
+          <a:bodyPr wrap="square">
+            <a:spAutoFit/>
+          </a:bodyPr>
+          <a:lstStyle/>
+          <a:p>
+            <a:pPr>
+              <a:spcAft>
+                <a:spcPts val="700"/>
+              </a:spcAft>
+            </a:pPr>
+            <a:r>
+              <a:rPr sz="1800">
+                <a:latin typeface="Verdana"/>
+              </a:rPr>
+              <a:t>The synthetic course taught the controller; the capstone drives the real KITTI route (drive 0005).</a:t>
+            </a:r>
+          </a:p>
+          <a:p>
+            <a:pPr>
+              <a:spcAft>
+                <a:spcPts val="700"/>
+              </a:spcAft>
+            </a:pPr>
+            <a:r>
+              <a:rPr sz="1500">
+                <a:latin typeface="Verdana"/>
+              </a:rPr>
+              <a:t>•  Same controller, real curved path</a:t>
+            </a:r>
+          </a:p>
+          <a:p>
+            <a:pPr>
+              <a:spcAft>
+                <a:spcPts val="700"/>
+              </a:spcAft>
+            </a:pPr>
+            <a:r>
+              <a:rPr sz="1500">
+                <a:latin typeface="Verdana"/>
+              </a:rPr>
+              <a:t>•  Bird's-eye view in N3's convention (forward up)</a:t>
+            </a:r>
+          </a:p>
+          <a:p>
+            <a:pPr>
+              <a:spcAft>
+                <a:spcPts val="700"/>
+              </a:spcAft>
+            </a:pPr>
+            <a:r>
+              <a:rPr sz="1500">
+                <a:latin typeface="Verdana"/>
+              </a:rPr>
+              <a:t>•  Hands directly to the capstone</a:t>
+            </a:r>
+          </a:p>
+        </p:txBody>
+      </p:sp>
+      <p:pic>
+        <p:nvPicPr>
+          <p:cNvPr id="4" name="Picture 3" descr="n4_realroute.png"/>
+          <p:cNvPicPr>
+            <a:picLocks noChangeAspect="1"/>
+          </p:cNvPicPr>
+          <p:nvPr/>
+        </p:nvPicPr>
+        <p:blipFill>
+          <a:blip r:embed="rId2"/>
+          <a:stretch>
+            <a:fillRect/>
+          </a:stretch>
+        </p:blipFill>
+        <p:spPr>
+          <a:xfrm>
+            <a:off x="7064902" y="1417320"/>
+            <a:ext cx="2603715" cy="5120640"/>
+          </a:xfrm>
+          <a:prstGeom prst="rect">
+            <a:avLst/>
+          </a:prstGeom>
+        </p:spPr>
+      </p:pic>
+    </p:spTree>
+  </p:cSld>
+  <p:clrMapOvr>
+    <a:masterClrMapping/>
+  </p:clrMapOvr>
+</p:sld>
+</file>
+
 <file path=ppt/slides/slide2.xml><?xml version="1.0" encoding="utf-8"?>
 <p:sld xmlns:a="http://schemas.openxmlformats.org/drawingml/2006/main" xmlns:p="http://schemas.openxmlformats.org/presentationml/2006/main" xmlns:r="http://schemas.openxmlformats.org/officeDocument/2006/relationships">
   <p:cSld>
@@ -30877,11 +31636,11 @@
           <a:p>
             <a:pPr>
               <a:spcAft>
-                <a:spcPts val="800"/>
+                <a:spcPts val="700"/>
               </a:spcAft>
             </a:pPr>
             <a:r>
-              <a:rPr sz="1800">
+              <a:rPr sz="1900">
                 <a:latin typeface="Verdana"/>
               </a:rPr>
               <a:t>N2 said the filter is an observer, not a controller — the controller is the next module. N3 hands us tracked objects; now we act.</a:t>
@@ -30890,7 +31649,7 @@
           <a:p>
             <a:pPr>
               <a:spcAft>
-                <a:spcPts val="800"/>
+                <a:spcPts val="700"/>
               </a:spcAft>
             </a:pPr>
             <a:r>
@@ -30903,7 +31662,7 @@
           <a:p>
             <a:pPr>
               <a:spcAft>
-                <a:spcPts val="800"/>
+                <a:spcPts val="700"/>
               </a:spcAft>
             </a:pPr>
             <a:r>
@@ -30916,7 +31675,7 @@
           <a:p>
             <a:pPr>
               <a:spcAft>
-                <a:spcPts val="800"/>
+                <a:spcPts val="700"/>
               </a:spcAft>
             </a:pPr>
             <a:r>
@@ -30978,8 +31737,8 @@
         </p:nvSpPr>
         <p:spPr>
           <a:xfrm>
-            <a:off x="566928" y="1600200"/>
-            <a:ext cx="11064240" cy="4663440"/>
+            <a:off x="502920" y="1600200"/>
+            <a:ext cx="4297680" cy="4572000"/>
           </a:xfrm>
           <a:prstGeom prst="rect">
             <a:avLst/>
@@ -30994,7 +31753,7 @@
           <a:p>
             <a:pPr>
               <a:spcAft>
-                <a:spcPts val="800"/>
+                <a:spcPts val="700"/>
               </a:spcAft>
             </a:pPr>
             <a:r>
@@ -31007,37 +31766,37 @@
           <a:p>
             <a:pPr>
               <a:spcAft>
-                <a:spcPts val="800"/>
+                <a:spcPts val="700"/>
               </a:spcAft>
             </a:pPr>
             <a:r>
-              <a:rPr sz="1600">
+              <a:rPr sz="1500">
                 <a:latin typeface="Verdana"/>
               </a:rPr>
-              <a:t>•  State [x, y, heading, v]; controls steering and acceleration</a:t>
+              <a:t>•  State [x, y, heading, v]</a:t>
             </a:r>
           </a:p>
           <a:p>
             <a:pPr>
               <a:spcAft>
-                <a:spcPts val="800"/>
+                <a:spcPts val="700"/>
               </a:spcAft>
             </a:pPr>
             <a:r>
-              <a:rPr sz="1600">
+              <a:rPr sz="1500">
                 <a:latin typeface="Verdana"/>
               </a:rPr>
-              <a:t>•  x' = v cos(psi), y' = v sin(psi), psi' = (v/L) tan(delta)</a:t>
+              <a:t>•  Controls: steering δ and acceleration</a:t>
             </a:r>
           </a:p>
           <a:p>
             <a:pPr>
               <a:spcAft>
-                <a:spcPts val="800"/>
+                <a:spcPts val="700"/>
               </a:spcAft>
             </a:pPr>
             <a:r>
-              <a:rPr sz="1600">
+              <a:rPr sz="1500">
                 <a:latin typeface="Verdana"/>
               </a:rPr>
               <a:t>•  One step forward = bicycle_step</a:t>
@@ -31045,6 +31804,30 @@
           </a:p>
         </p:txBody>
       </p:sp>
+      <p:pic>
+        <p:nvPicPr>
+          <p:cNvPr id="4" name="Picture 3" descr="n4_bicycle.png"/>
+          <p:cNvPicPr>
+            <a:picLocks noChangeAspect="1"/>
+          </p:cNvPicPr>
+          <p:nvPr/>
+        </p:nvPicPr>
+        <p:blipFill>
+          <a:blip r:embed="rId2"/>
+          <a:stretch>
+            <a:fillRect/>
+          </a:stretch>
+        </p:blipFill>
+        <p:spPr>
+          <a:xfrm>
+            <a:off x="4983480" y="2705731"/>
+            <a:ext cx="6766560" cy="2543818"/>
+          </a:xfrm>
+          <a:prstGeom prst="rect">
+            <a:avLst/>
+          </a:prstGeom>
+        </p:spPr>
+      </p:pic>
     </p:spTree>
   </p:cSld>
   <p:clrMapOvr>
@@ -31082,7 +31865,7 @@
               <a:rPr>
                 <a:latin typeface="Verdana"/>
               </a:rPr>
-              <a:t>Pure pursuit</a:t>
+              <a:t>The bicycle model in equations</a:t>
             </a:r>
           </a:p>
         </p:txBody>
@@ -31095,8 +31878,8 @@
         </p:nvSpPr>
         <p:spPr>
           <a:xfrm>
-            <a:off x="566928" y="1600200"/>
-            <a:ext cx="11064240" cy="4663440"/>
+            <a:off x="566928" y="1417320"/>
+            <a:ext cx="11064240" cy="868680"/>
           </a:xfrm>
           <a:prstGeom prst="rect">
             <a:avLst/>
@@ -31111,53 +31894,100 @@
           <a:p>
             <a:pPr>
               <a:spcAft>
-                <a:spcPts val="800"/>
+                <a:spcPts val="700"/>
               </a:spcAft>
             </a:pPr>
             <a:r>
               <a:rPr sz="1800">
                 <a:latin typeface="Verdana"/>
               </a:rPr>
-              <a:t>Aim at a point a fixed distance ahead and steer toward it.</a:t>
+              <a:t>Four states, two controls — integrate forward each tick.</a:t>
+            </a:r>
+          </a:p>
+        </p:txBody>
+      </p:sp>
+      <p:pic>
+        <p:nvPicPr>
+          <p:cNvPr id="4" name="Picture 3" descr="eq_bicycle.png"/>
+          <p:cNvPicPr>
+            <a:picLocks noChangeAspect="1"/>
+          </p:cNvPicPr>
+          <p:nvPr/>
+        </p:nvPicPr>
+        <p:blipFill>
+          <a:blip r:embed="rId2"/>
+          <a:stretch>
+            <a:fillRect/>
+          </a:stretch>
+        </p:blipFill>
+        <p:spPr>
+          <a:xfrm>
+            <a:off x="4475148" y="2468880"/>
+            <a:ext cx="3119783" cy="2377440"/>
+          </a:xfrm>
+          <a:prstGeom prst="rect">
+            <a:avLst/>
+          </a:prstGeom>
+        </p:spPr>
+      </p:pic>
+      <p:sp>
+        <p:nvSpPr>
+          <p:cNvPr id="5" name="TextBox 4"/>
+          <p:cNvSpPr txBox="1"/>
+          <p:nvPr/>
+        </p:nvSpPr>
+        <p:spPr>
+          <a:xfrm>
+            <a:off x="566928" y="5120640"/>
+            <a:ext cx="11064240" cy="1371600"/>
+          </a:xfrm>
+          <a:prstGeom prst="rect">
+            <a:avLst/>
+          </a:prstGeom>
+          <a:noFill/>
+        </p:spPr>
+        <p:txBody>
+          <a:bodyPr wrap="square">
+            <a:spAutoFit/>
+          </a:bodyPr>
+          <a:lstStyle/>
+          <a:p>
+            <a:pPr>
+              <a:spcAft>
+                <a:spcPts val="700"/>
+              </a:spcAft>
+            </a:pPr>
+            <a:r>
+              <a:rPr sz="1500">
+                <a:latin typeface="Verdana"/>
+              </a:rPr>
+              <a:t>x, y position; ψ heading; v speed</a:t>
             </a:r>
           </a:p>
           <a:p>
             <a:pPr>
               <a:spcAft>
-                <a:spcPts val="800"/>
+                <a:spcPts val="700"/>
               </a:spcAft>
             </a:pPr>
             <a:r>
-              <a:rPr sz="1600">
+              <a:rPr sz="1400">
                 <a:latin typeface="Verdana"/>
               </a:rPr>
-              <a:t>•  One knob: the lookahead distance L_d</a:t>
+              <a:t>•  δ steering and a acceleration are the inputs</a:t>
             </a:r>
           </a:p>
           <a:p>
             <a:pPr>
               <a:spcAft>
-                <a:spcPts val="800"/>
+                <a:spcPts val="700"/>
               </a:spcAft>
             </a:pPr>
             <a:r>
-              <a:rPr sz="1600">
+              <a:rPr sz="1400">
                 <a:latin typeface="Verdana"/>
               </a:rPr>
-              <a:t>•  Short L_d = twitchy; long L_d = lazy, cuts corners</a:t>
-            </a:r>
-          </a:p>
-          <a:p>
-            <a:pPr>
-              <a:spcAft>
-                <a:spcPts val="800"/>
-              </a:spcAft>
-            </a:pPr>
-            <a:r>
-              <a:rPr sz="1600">
-                <a:latin typeface="Verdana"/>
-              </a:rPr>
-              <a:t>•  delta = atan(2 L sin(alpha) / L_d)</a:t>
+              <a:t>•  Stepped by Δt in bicycle_step — plain forward-Euler</a:t>
             </a:r>
           </a:p>
         </p:txBody>
@@ -31199,7 +32029,7 @@
               <a:rPr>
                 <a:latin typeface="Verdana"/>
               </a:rPr>
-              <a:t>Stanley</a:t>
+              <a:t>Pure pursuit</a:t>
             </a:r>
           </a:p>
         </p:txBody>
@@ -31212,8 +32042,8 @@
         </p:nvSpPr>
         <p:spPr>
           <a:xfrm>
-            <a:off x="566928" y="1600200"/>
-            <a:ext cx="11064240" cy="4663440"/>
+            <a:off x="502920" y="1600200"/>
+            <a:ext cx="4297680" cy="4572000"/>
           </a:xfrm>
           <a:prstGeom prst="rect">
             <a:avLst/>
@@ -31228,57 +32058,81 @@
           <a:p>
             <a:pPr>
               <a:spcAft>
-                <a:spcPts val="800"/>
+                <a:spcPts val="700"/>
               </a:spcAft>
             </a:pPr>
             <a:r>
               <a:rPr sz="1800">
                 <a:latin typeface="Verdana"/>
               </a:rPr>
-              <a:t>Cancel heading error and cross-track error together.</a:t>
+              <a:t>Aim at a point a fixed distance ahead and steer toward it.</a:t>
             </a:r>
           </a:p>
           <a:p>
             <a:pPr>
               <a:spcAft>
-                <a:spcPts val="800"/>
+                <a:spcPts val="700"/>
               </a:spcAft>
             </a:pPr>
             <a:r>
-              <a:rPr sz="1600">
+              <a:rPr sz="1500">
                 <a:latin typeface="Verdana"/>
               </a:rPr>
-              <a:t>•  Steers from the FRONT axle reference</a:t>
+              <a:t>•  One knob: the lookahead L_d</a:t>
             </a:r>
           </a:p>
           <a:p>
             <a:pPr>
               <a:spcAft>
-                <a:spcPts val="800"/>
+                <a:spcPts val="700"/>
               </a:spcAft>
             </a:pPr>
             <a:r>
-              <a:rPr sz="1600">
+              <a:rPr sz="1500">
                 <a:latin typeface="Verdana"/>
               </a:rPr>
-              <a:t>•  Hugs the path harder than pure pursuit</a:t>
+              <a:t>•  Short = twitchy; long = cuts corners</a:t>
             </a:r>
           </a:p>
           <a:p>
             <a:pPr>
               <a:spcAft>
-                <a:spcPts val="800"/>
+                <a:spcPts val="700"/>
               </a:spcAft>
             </a:pPr>
             <a:r>
-              <a:rPr sz="1600">
+              <a:rPr sz="1500">
                 <a:latin typeface="Verdana"/>
               </a:rPr>
-              <a:t>•  The DARPA Grand Challenge winner</a:t>
+              <a:t>•  δ = atan(2 L sin α / L_d)</a:t>
             </a:r>
           </a:p>
         </p:txBody>
       </p:sp>
+      <p:pic>
+        <p:nvPicPr>
+          <p:cNvPr id="4" name="Picture 3" descr="n4_pursuit.png"/>
+          <p:cNvPicPr>
+            <a:picLocks noChangeAspect="1"/>
+          </p:cNvPicPr>
+          <p:nvPr/>
+        </p:nvPicPr>
+        <p:blipFill>
+          <a:blip r:embed="rId2"/>
+          <a:stretch>
+            <a:fillRect/>
+          </a:stretch>
+        </p:blipFill>
+        <p:spPr>
+          <a:xfrm>
+            <a:off x="4983480" y="2224027"/>
+            <a:ext cx="6766560" cy="3507226"/>
+          </a:xfrm>
+          <a:prstGeom prst="rect">
+            <a:avLst/>
+          </a:prstGeom>
+        </p:spPr>
+      </p:pic>
     </p:spTree>
   </p:cSld>
   <p:clrMapOvr>
@@ -31316,7 +32170,7 @@
               <a:rPr>
                 <a:latin typeface="Verdana"/>
               </a:rPr>
-              <a:t>Tuning the tradeoff</a:t>
+              <a:t>Pure pursuit, derived</a:t>
             </a:r>
           </a:p>
         </p:txBody>
@@ -31329,8 +32183,8 @@
         </p:nvSpPr>
         <p:spPr>
           <a:xfrm>
-            <a:off x="566928" y="1600200"/>
-            <a:ext cx="11064240" cy="4663440"/>
+            <a:off x="566928" y="1417320"/>
+            <a:ext cx="11064240" cy="868680"/>
           </a:xfrm>
           <a:prstGeom prst="rect">
             <a:avLst/>
@@ -31345,53 +32199,100 @@
           <a:p>
             <a:pPr>
               <a:spcAft>
-                <a:spcPts val="800"/>
+                <a:spcPts val="700"/>
               </a:spcAft>
             </a:pPr>
             <a:r>
               <a:rPr sz="1800">
                 <a:latin typeface="Verdana"/>
               </a:rPr>
-              <a:t>Aggression vs stability vs accuracy.</a:t>
+              <a:t>Fit a circular arc through the rear axle and the lookahead point.</a:t>
+            </a:r>
+          </a:p>
+        </p:txBody>
+      </p:sp>
+      <p:pic>
+        <p:nvPicPr>
+          <p:cNvPr id="4" name="Picture 3" descr="eq_pursuit.png"/>
+          <p:cNvPicPr>
+            <a:picLocks noChangeAspect="1"/>
+          </p:cNvPicPr>
+          <p:nvPr/>
+        </p:nvPicPr>
+        <p:blipFill>
+          <a:blip r:embed="rId2"/>
+          <a:stretch>
+            <a:fillRect/>
+          </a:stretch>
+        </p:blipFill>
+        <p:spPr>
+          <a:xfrm>
+            <a:off x="4097166" y="2468880"/>
+            <a:ext cx="3875747" cy="2377440"/>
+          </a:xfrm>
+          <a:prstGeom prst="rect">
+            <a:avLst/>
+          </a:prstGeom>
+        </p:spPr>
+      </p:pic>
+      <p:sp>
+        <p:nvSpPr>
+          <p:cNvPr id="5" name="TextBox 4"/>
+          <p:cNvSpPr txBox="1"/>
+          <p:nvPr/>
+        </p:nvSpPr>
+        <p:spPr>
+          <a:xfrm>
+            <a:off x="566928" y="5120640"/>
+            <a:ext cx="11064240" cy="1371600"/>
+          </a:xfrm>
+          <a:prstGeom prst="rect">
+            <a:avLst/>
+          </a:prstGeom>
+          <a:noFill/>
+        </p:spPr>
+        <p:txBody>
+          <a:bodyPr wrap="square">
+            <a:spAutoFit/>
+          </a:bodyPr>
+          <a:lstStyle/>
+          <a:p>
+            <a:pPr>
+              <a:spcAft>
+                <a:spcPts val="700"/>
+              </a:spcAft>
+            </a:pPr>
+            <a:r>
+              <a:rPr sz="1500">
+                <a:latin typeface="Verdana"/>
+              </a:rPr>
+              <a:t>α = angle from the heading to the lookahead point</a:t>
             </a:r>
           </a:p>
           <a:p>
             <a:pPr>
               <a:spcAft>
-                <a:spcPts val="800"/>
+                <a:spcPts val="700"/>
               </a:spcAft>
             </a:pPr>
             <a:r>
-              <a:rPr sz="1600">
+              <a:rPr sz="1400">
                 <a:latin typeface="Verdana"/>
               </a:rPr>
-              <a:t>•  Sweep the lookahead and watch cross-track error</a:t>
+              <a:t>•  Larger L_d ⇒ gentler steer (smaller curvature)</a:t>
             </a:r>
           </a:p>
           <a:p>
             <a:pPr>
               <a:spcAft>
-                <a:spcPts val="800"/>
+                <a:spcPts val="700"/>
               </a:spcAft>
             </a:pPr>
             <a:r>
-              <a:rPr sz="1600">
+              <a:rPr sz="1400">
                 <a:latin typeface="Verdana"/>
               </a:rPr>
-              <a:t>•  Too short oscillates; too long drifts on curves</a:t>
-            </a:r>
-          </a:p>
-          <a:p>
-            <a:pPr>
-              <a:spcAft>
-                <a:spcPts val="800"/>
-              </a:spcAft>
-            </a:pPr>
-            <a:r>
-              <a:rPr sz="1600">
-                <a:latin typeface="Verdana"/>
-              </a:rPr>
-              <a:t>•  Pick the sweet spot for your speed</a:t>
+              <a:t>•  Curvature κ = 2 sin α / L_d</a:t>
             </a:r>
           </a:p>
         </p:txBody>
@@ -31433,7 +32334,7 @@
               <a:rPr>
                 <a:latin typeface="Verdana"/>
               </a:rPr>
-              <a:t>Tracking the real route</a:t>
+              <a:t>Stanley</a:t>
             </a:r>
           </a:p>
         </p:txBody>
@@ -31446,8 +32347,8 @@
         </p:nvSpPr>
         <p:spPr>
           <a:xfrm>
-            <a:off x="566928" y="1600200"/>
-            <a:ext cx="11064240" cy="4663440"/>
+            <a:off x="502920" y="1600200"/>
+            <a:ext cx="4297680" cy="4572000"/>
           </a:xfrm>
           <a:prstGeom prst="rect">
             <a:avLst/>
@@ -31462,57 +32363,386 @@
           <a:p>
             <a:pPr>
               <a:spcAft>
-                <a:spcPts val="800"/>
+                <a:spcPts val="700"/>
               </a:spcAft>
             </a:pPr>
             <a:r>
               <a:rPr sz="1800">
                 <a:latin typeface="Verdana"/>
               </a:rPr>
-              <a:t>The synthetic course taught the controller; the capstone drives the real KITTI trajectory (drive 0005) — with obstacles in the way (N5).</a:t>
+              <a:t>Cancel heading error and cross-track error together.</a:t>
             </a:r>
           </a:p>
           <a:p>
             <a:pPr>
               <a:spcAft>
-                <a:spcPts val="800"/>
+                <a:spcPts val="700"/>
               </a:spcAft>
             </a:pPr>
             <a:r>
-              <a:rPr sz="1600">
+              <a:rPr sz="1500">
                 <a:latin typeface="Verdana"/>
               </a:rPr>
-              <a:t>•  Same controller, real curved path</a:t>
+              <a:t>•  Steers from the FRONT axle</a:t>
             </a:r>
           </a:p>
           <a:p>
             <a:pPr>
               <a:spcAft>
-                <a:spcPts val="800"/>
+                <a:spcPts val="700"/>
               </a:spcAft>
             </a:pPr>
             <a:r>
-              <a:rPr sz="1600">
+              <a:rPr sz="1500">
                 <a:latin typeface="Verdana"/>
               </a:rPr>
-              <a:t>•  Bird's-eye view in N3's convention (forward up)</a:t>
+              <a:t>•  Hugs the path harder than pure pursuit</a:t>
             </a:r>
           </a:p>
           <a:p>
             <a:pPr>
               <a:spcAft>
-                <a:spcPts val="800"/>
+                <a:spcPts val="700"/>
               </a:spcAft>
             </a:pPr>
             <a:r>
-              <a:rPr sz="1600">
+              <a:rPr sz="1500">
                 <a:latin typeface="Verdana"/>
               </a:rPr>
-              <a:t>•  Hands directly to the capstone</a:t>
+              <a:t>•  The DARPA Grand Challenge winner</a:t>
             </a:r>
           </a:p>
         </p:txBody>
       </p:sp>
+      <p:pic>
+        <p:nvPicPr>
+          <p:cNvPr id="4" name="Picture 3" descr="n4_stanley.png"/>
+          <p:cNvPicPr>
+            <a:picLocks noChangeAspect="1"/>
+          </p:cNvPicPr>
+          <p:nvPr/>
+        </p:nvPicPr>
+        <p:blipFill>
+          <a:blip r:embed="rId2"/>
+          <a:stretch>
+            <a:fillRect/>
+          </a:stretch>
+        </p:blipFill>
+        <p:spPr>
+          <a:xfrm>
+            <a:off x="5018011" y="1417320"/>
+            <a:ext cx="6697497" cy="5120640"/>
+          </a:xfrm>
+          <a:prstGeom prst="rect">
+            <a:avLst/>
+          </a:prstGeom>
+        </p:spPr>
+      </p:pic>
+    </p:spTree>
+  </p:cSld>
+  <p:clrMapOvr>
+    <a:masterClrMapping/>
+  </p:clrMapOvr>
+</p:sld>
+</file>
+
+<file path=ppt/slides/slide8.xml><?xml version="1.0" encoding="utf-8"?>
+<p:sld xmlns:a="http://schemas.openxmlformats.org/drawingml/2006/main" xmlns:p="http://schemas.openxmlformats.org/presentationml/2006/main" xmlns:r="http://schemas.openxmlformats.org/officeDocument/2006/relationships">
+  <p:cSld>
+    <p:spTree>
+      <p:nvGrpSpPr>
+        <p:cNvPr id="1" name=""/>
+        <p:cNvGrpSpPr/>
+        <p:nvPr/>
+      </p:nvGrpSpPr>
+      <p:grpSpPr/>
+      <p:sp>
+        <p:nvSpPr>
+          <p:cNvPr id="2" name="Title 1"/>
+          <p:cNvSpPr>
+            <a:spLocks noGrp="1"/>
+          </p:cNvSpPr>
+          <p:nvPr>
+            <p:ph type="title"/>
+          </p:nvPr>
+        </p:nvSpPr>
+        <p:spPr/>
+        <p:txBody>
+          <a:bodyPr/>
+          <a:lstStyle/>
+          <a:p>
+            <a:r>
+              <a:rPr>
+                <a:latin typeface="Verdana"/>
+              </a:rPr>
+              <a:t>Stanley, the control law</a:t>
+            </a:r>
+          </a:p>
+        </p:txBody>
+      </p:sp>
+      <p:sp>
+        <p:nvSpPr>
+          <p:cNvPr id="3" name="TextBox 2"/>
+          <p:cNvSpPr txBox="1"/>
+          <p:nvPr/>
+        </p:nvSpPr>
+        <p:spPr>
+          <a:xfrm>
+            <a:off x="566928" y="1417320"/>
+            <a:ext cx="11064240" cy="868680"/>
+          </a:xfrm>
+          <a:prstGeom prst="rect">
+            <a:avLst/>
+          </a:prstGeom>
+          <a:noFill/>
+        </p:spPr>
+        <p:txBody>
+          <a:bodyPr wrap="square">
+            <a:spAutoFit/>
+          </a:bodyPr>
+          <a:lstStyle/>
+          <a:p>
+            <a:pPr>
+              <a:spcAft>
+                <a:spcPts val="700"/>
+              </a:spcAft>
+            </a:pPr>
+            <a:r>
+              <a:rPr sz="1800">
+                <a:latin typeface="Verdana"/>
+              </a:rPr>
+              <a:t>Two terms: align the heading, then kill the lateral offset.</a:t>
+            </a:r>
+          </a:p>
+        </p:txBody>
+      </p:sp>
+      <p:pic>
+        <p:nvPicPr>
+          <p:cNvPr id="4" name="Picture 3" descr="eq_stanley.png"/>
+          <p:cNvPicPr>
+            <a:picLocks noChangeAspect="1"/>
+          </p:cNvPicPr>
+          <p:nvPr/>
+        </p:nvPicPr>
+        <p:blipFill>
+          <a:blip r:embed="rId2"/>
+          <a:stretch>
+            <a:fillRect/>
+          </a:stretch>
+        </p:blipFill>
+        <p:spPr>
+          <a:xfrm>
+            <a:off x="1005840" y="2568355"/>
+            <a:ext cx="10058400" cy="2178490"/>
+          </a:xfrm>
+          <a:prstGeom prst="rect">
+            <a:avLst/>
+          </a:prstGeom>
+        </p:spPr>
+      </p:pic>
+      <p:sp>
+        <p:nvSpPr>
+          <p:cNvPr id="5" name="TextBox 4"/>
+          <p:cNvSpPr txBox="1"/>
+          <p:nvPr/>
+        </p:nvSpPr>
+        <p:spPr>
+          <a:xfrm>
+            <a:off x="566928" y="5120640"/>
+            <a:ext cx="11064240" cy="1371600"/>
+          </a:xfrm>
+          <a:prstGeom prst="rect">
+            <a:avLst/>
+          </a:prstGeom>
+          <a:noFill/>
+        </p:spPr>
+        <p:txBody>
+          <a:bodyPr wrap="square">
+            <a:spAutoFit/>
+          </a:bodyPr>
+          <a:lstStyle/>
+          <a:p>
+            <a:pPr>
+              <a:spcAft>
+                <a:spcPts val="700"/>
+              </a:spcAft>
+            </a:pPr>
+            <a:r>
+              <a:rPr sz="1500">
+                <a:latin typeface="Verdana"/>
+              </a:rPr>
+              <a:t>First term: path heading − vehicle heading (point the right way)</a:t>
+            </a:r>
+          </a:p>
+          <a:p>
+            <a:pPr>
+              <a:spcAft>
+                <a:spcPts val="700"/>
+              </a:spcAft>
+            </a:pPr>
+            <a:r>
+              <a:rPr sz="1400">
+                <a:latin typeface="Verdana"/>
+              </a:rPr>
+              <a:t>•  Second term: cross-track error e, gain k, speed v (slide back onto the line)</a:t>
+            </a:r>
+          </a:p>
+          <a:p>
+            <a:pPr>
+              <a:spcAft>
+                <a:spcPts val="700"/>
+              </a:spcAft>
+            </a:pPr>
+            <a:r>
+              <a:rPr sz="1400">
+                <a:latin typeface="Verdana"/>
+              </a:rPr>
+              <a:t>•  arctan bounds the correction; ÷v softens it at speed</a:t>
+            </a:r>
+          </a:p>
+        </p:txBody>
+      </p:sp>
+    </p:spTree>
+  </p:cSld>
+  <p:clrMapOvr>
+    <a:masterClrMapping/>
+  </p:clrMapOvr>
+</p:sld>
+</file>
+
+<file path=ppt/slides/slide9.xml><?xml version="1.0" encoding="utf-8"?>
+<p:sld xmlns:a="http://schemas.openxmlformats.org/drawingml/2006/main" xmlns:p="http://schemas.openxmlformats.org/presentationml/2006/main" xmlns:r="http://schemas.openxmlformats.org/officeDocument/2006/relationships">
+  <p:cSld>
+    <p:spTree>
+      <p:nvGrpSpPr>
+        <p:cNvPr id="1" name=""/>
+        <p:cNvGrpSpPr/>
+        <p:nvPr/>
+      </p:nvGrpSpPr>
+      <p:grpSpPr/>
+      <p:sp>
+        <p:nvSpPr>
+          <p:cNvPr id="2" name="Title 1"/>
+          <p:cNvSpPr>
+            <a:spLocks noGrp="1"/>
+          </p:cNvSpPr>
+          <p:nvPr>
+            <p:ph type="title"/>
+          </p:nvPr>
+        </p:nvSpPr>
+        <p:spPr/>
+        <p:txBody>
+          <a:bodyPr/>
+          <a:lstStyle/>
+          <a:p>
+            <a:r>
+              <a:rPr>
+                <a:latin typeface="Verdana"/>
+              </a:rPr>
+              <a:t>Tuning the tradeoff</a:t>
+            </a:r>
+          </a:p>
+        </p:txBody>
+      </p:sp>
+      <p:sp>
+        <p:nvSpPr>
+          <p:cNvPr id="3" name="TextBox 2"/>
+          <p:cNvSpPr txBox="1"/>
+          <p:nvPr/>
+        </p:nvSpPr>
+        <p:spPr>
+          <a:xfrm>
+            <a:off x="502920" y="1600200"/>
+            <a:ext cx="4297680" cy="4572000"/>
+          </a:xfrm>
+          <a:prstGeom prst="rect">
+            <a:avLst/>
+          </a:prstGeom>
+          <a:noFill/>
+        </p:spPr>
+        <p:txBody>
+          <a:bodyPr wrap="square">
+            <a:spAutoFit/>
+          </a:bodyPr>
+          <a:lstStyle/>
+          <a:p>
+            <a:pPr>
+              <a:spcAft>
+                <a:spcPts val="700"/>
+              </a:spcAft>
+            </a:pPr>
+            <a:r>
+              <a:rPr sz="1800">
+                <a:latin typeface="Verdana"/>
+              </a:rPr>
+              <a:t>Aggression vs stability vs accuracy.</a:t>
+            </a:r>
+          </a:p>
+          <a:p>
+            <a:pPr>
+              <a:spcAft>
+                <a:spcPts val="700"/>
+              </a:spcAft>
+            </a:pPr>
+            <a:r>
+              <a:rPr sz="1500">
+                <a:latin typeface="Verdana"/>
+              </a:rPr>
+              <a:t>•  Sweep the lookahead, watch cross-track error</a:t>
+            </a:r>
+          </a:p>
+          <a:p>
+            <a:pPr>
+              <a:spcAft>
+                <a:spcPts val="700"/>
+              </a:spcAft>
+            </a:pPr>
+            <a:r>
+              <a:rPr sz="1500">
+                <a:latin typeface="Verdana"/>
+              </a:rPr>
+              <a:t>•  Too short oscillates; too long drifts</a:t>
+            </a:r>
+          </a:p>
+          <a:p>
+            <a:pPr>
+              <a:spcAft>
+                <a:spcPts val="700"/>
+              </a:spcAft>
+            </a:pPr>
+            <a:r>
+              <a:rPr sz="1500">
+                <a:latin typeface="Verdana"/>
+              </a:rPr>
+              <a:t>•  Real runs on the synthetic course</a:t>
+            </a:r>
+          </a:p>
+        </p:txBody>
+      </p:sp>
+      <p:pic>
+        <p:nvPicPr>
+          <p:cNvPr id="4" name="Picture 3" descr="n4_sweep.png"/>
+          <p:cNvPicPr>
+            <a:picLocks noChangeAspect="1"/>
+          </p:cNvPicPr>
+          <p:nvPr/>
+        </p:nvPicPr>
+        <p:blipFill>
+          <a:blip r:embed="rId2"/>
+          <a:stretch>
+            <a:fillRect/>
+          </a:stretch>
+        </p:blipFill>
+        <p:spPr>
+          <a:xfrm>
+            <a:off x="6174240" y="1417320"/>
+            <a:ext cx="4385039" cy="5120640"/>
+          </a:xfrm>
+          <a:prstGeom prst="rect">
+            <a:avLst/>
+          </a:prstGeom>
+        </p:spPr>
+      </p:pic>
     </p:spTree>
   </p:cSld>
   <p:clrMapOvr>

</xml_diff>